<commit_message>
Atualiza nome no slide final da apresentação
</commit_message>
<xml_diff>
--- a/docs/entrega/Apresentacao-Classificador-de-Ambiente.pptx
+++ b/docs/entrega/Apresentacao-Classificador-de-Ambiente.pptx
@@ -124,20 +124,20 @@
   <p:extLst>
     <p:ext uri="{521415D9-36F7-43E2-AB2F-B90AF26B5E84}">
       <p14:sectionLst xmlns:p14="http://schemas.microsoft.com/office/powerpoint/2010/main">
-        <p14:section name="Introdução" id="{feb2d81f-ddf2-6118-ce75-36bfa8633261}">
+        <p14:section name="Introdução" id="{430d8084-e52b-12ae-c775-d97a73e6800b}">
           <p14:sldIdLst>
             <p14:sldId id="256"/>
             <p14:sldId id="257"/>
             <p14:sldId id="258"/>
           </p14:sldIdLst>
         </p14:section>
-        <p14:section name="Hardware e testes iniciais" id="{a62db21d-cf53-d12e-c12a-2edb49dbc47b}">
+        <p14:section name="Hardware e testes iniciais" id="{139ff67f-f3a6-ce44-8b74-448bd5392502}">
           <p14:sldIdLst>
             <p14:sldId id="259"/>
             <p14:sldId id="260"/>
           </p14:sldIdLst>
         </p14:section>
-        <p14:section name="Dados e modelo" id="{2b9e246d-e7fd-a5e1-5072-787ad5ad7e41}">
+        <p14:section name="Dados e modelo" id="{9f68146c-c6d7-324e-5dd7-898f835d251d}">
           <p14:sldIdLst>
             <p14:sldId id="261"/>
             <p14:sldId id="262"/>
@@ -146,7 +146,7 @@
             <p14:sldId id="265"/>
           </p14:sldIdLst>
         </p14:section>
-        <p14:section name="Embarcado" id="{bc386dd5-f5d4-a86e-282a-c1b9095e9878}">
+        <p14:section name="Embarcado" id="{7ce1bbc2-645e-6dcb-80e6-a56a0bb76bf1}">
           <p14:sldIdLst>
             <p14:sldId id="266"/>
             <p14:sldId id="267"/>
@@ -154,13 +154,13 @@
             <p14:sldId id="269"/>
           </p14:sldIdLst>
         </p14:section>
-        <p14:section name="Produto" id="{3720d5df-b7ba-5342-7f99-7213935a0776}">
+        <p14:section name="Produto" id="{db73f74f-4f5d-2955-a171-e5e3f362d44c}">
           <p14:sldIdLst>
             <p14:sldId id="270"/>
             <p14:sldId id="271"/>
           </p14:sldIdLst>
         </p14:section>
-        <p14:section name="Conclusão" id="{6074ada9-57cd-7308-9013-01ed1191c589}">
+        <p14:section name="Conclusão" id="{665790a2-52d1-4e29-d263-3aca856341fa}">
           <p14:sldIdLst>
             <p14:sldId id="272"/>
             <p14:sldId id="273"/>
@@ -13135,7 +13135,7 @@
                   <a:srgbClr val="FFFFFF"/>
                 </a:solidFill>
               </a:rPr>
-              <a:t>Rafaela Santana  ·  Miriam  ·  Sara Coutinho</a:t>
+              <a:t>Rafaela Santana  ·  Miriam Aguiar  ·  Sara Coutinho</a:t>
             </a:r>
             <a:endParaRPr lang="en-US" sz="1300" dirty="0"/>
           </a:p>

</xml_diff>

<commit_message>
Atualiza nome da integrante Miriam Aguiar na apresentação
</commit_message>
<xml_diff>
--- a/docs/entrega/Apresentacao-Classificador-de-Ambiente.pptx
+++ b/docs/entrega/Apresentacao-Classificador-de-Ambiente.pptx
@@ -124,20 +124,20 @@
   <p:extLst>
     <p:ext uri="{521415D9-36F7-43E2-AB2F-B90AF26B5E84}">
       <p14:sectionLst xmlns:p14="http://schemas.microsoft.com/office/powerpoint/2010/main">
-        <p14:section name="Introdução" id="{430d8084-e52b-12ae-c775-d97a73e6800b}">
+        <p14:section name="Introdução" id="{b38a3b94-8447-62a3-82bb-2f8e64df8ff0}">
           <p14:sldIdLst>
             <p14:sldId id="256"/>
             <p14:sldId id="257"/>
             <p14:sldId id="258"/>
           </p14:sldIdLst>
         </p14:section>
-        <p14:section name="Hardware e testes iniciais" id="{139ff67f-f3a6-ce44-8b74-448bd5392502}">
+        <p14:section name="Hardware e testes iniciais" id="{8f160ea4-ae59-da4b-bfc7-308a13cd2975}">
           <p14:sldIdLst>
             <p14:sldId id="259"/>
             <p14:sldId id="260"/>
           </p14:sldIdLst>
         </p14:section>
-        <p14:section name="Dados e modelo" id="{9f68146c-c6d7-324e-5dd7-898f835d251d}">
+        <p14:section name="Dados e modelo" id="{a6f2a077-8327-86c8-8c96-afb7a5da9356}">
           <p14:sldIdLst>
             <p14:sldId id="261"/>
             <p14:sldId id="262"/>
@@ -146,7 +146,7 @@
             <p14:sldId id="265"/>
           </p14:sldIdLst>
         </p14:section>
-        <p14:section name="Embarcado" id="{7ce1bbc2-645e-6dcb-80e6-a56a0bb76bf1}">
+        <p14:section name="Embarcado" id="{b368a336-3588-dd1b-b7e0-028e68b68697}">
           <p14:sldIdLst>
             <p14:sldId id="266"/>
             <p14:sldId id="267"/>
@@ -154,13 +154,13 @@
             <p14:sldId id="269"/>
           </p14:sldIdLst>
         </p14:section>
-        <p14:section name="Produto" id="{db73f74f-4f5d-2955-a171-e5e3f362d44c}">
+        <p14:section name="Produto" id="{a7398df0-af20-f055-8803-755f32a3444c}">
           <p14:sldIdLst>
             <p14:sldId id="270"/>
             <p14:sldId id="271"/>
           </p14:sldIdLst>
         </p14:section>
-        <p14:section name="Conclusão" id="{665790a2-52d1-4e29-d263-3aca856341fa}">
+        <p14:section name="Conclusão" id="{80e859af-9247-6d2f-88d5-5aba7be5da92}">
           <p14:sldIdLst>
             <p14:sldId id="272"/>
             <p14:sldId id="273"/>
@@ -1374,7 +1374,7 @@
           <a:p>
             <a:r>
               <a:rPr lang="en-US" dirty="0"/>
-              <a:t>Apresentar a equipe (Rafaela Santana, Miriam e Sara Coutinho) e a unidade curricular IA Embarcada e Modelos Compactos, com o professor Rodrigo Kobashikawa Rosa. Depois, apresentar o projeto: um sistema que lê temperatura, umidade e presença e classifica o ambiente em quatro estados dentro da própria placa, sem depender de nuvem. A foto mostra os componentes usados no início da montagem.</a:t>
+              <a:t>Apresentar a equipe (Rafaela Santana, Miriam Aguiar e Sara Coutinho) e a unidade curricular IA Embarcada e Modelos Compactos, com o professor Rodrigo Kobashikawa Rosa. Depois, apresentar o projeto: um sistema que lê temperatura, umidade e presença e classifica o ambiente em quatro estados dentro da própria placa, sem depender de nuvem. A foto mostra os componentes usados no início da montagem.</a:t>
             </a:r>
             <a:endParaRPr lang="en-US" dirty="0"/>
           </a:p>
@@ -4332,7 +4332,7 @@
                   <a:srgbClr val="FFFFFF"/>
                 </a:solidFill>
               </a:rPr>
-              <a:t>Rafaela Santana  ·  Miriam  ·  Sara Coutinho</a:t>
+              <a:t>Rafaela Santana  ·  Miriam Aguiar  ·  Sara Coutinho</a:t>
             </a:r>
             <a:endParaRPr lang="en-US" sz="1400" dirty="0"/>
           </a:p>

</xml_diff>